<commit_message>
feat(sesi-03): audit tuntas 18 berkas html ramah awam diagram svg valid xml naskah mermaid dan pptx tugas 1
</commit_message>
<xml_diff>
--- a/slide_presentasi/SESI_03_TypeScript_dan_Komposisi_Vue.pptx
+++ b/slide_presentasi/SESI_03_TypeScript_dan_Komposisi_Vue.pptx
@@ -3245,7 +3245,7 @@
         <p:spPr>
           <a:xfrm>
             <a:off x="1280160" y="1188720"/>
-            <a:ext cx="9601200" cy="4389120"/>
+            <a:ext cx="9601200" cy="3931920"/>
           </a:xfrm>
           <a:prstGeom prst="rect">
             <a:avLst/>
@@ -3292,7 +3292,7 @@
           <a:p>
             <a:pPr>
               <a:spcAft>
-                <a:spcPts val="3600"/>
+                <a:spcPts val="2600"/>
               </a:spcAft>
               <a:defRPr sz="1350">
                 <a:solidFill>
@@ -3320,6 +3320,89 @@
             </a:pPr>
             <a:r>
               <a:t>■  Anton Prafanto, S.Kom., M.T.  ■  FAKULTAS SAINS DAN TEKNOLOGI • UNIVERSITAS TERBUKA</a:t>
+            </a:r>
+          </a:p>
+        </p:txBody>
+      </p:sp>
+      <p:sp>
+        <p:nvSpPr>
+          <p:cNvPr id="6" name="Rectangle 5">
+            <a:hlinkClick r:id="rId2"/>
+          </p:cNvPr>
+          <p:cNvSpPr/>
+          <p:nvPr/>
+        </p:nvSpPr>
+        <p:spPr>
+          <a:xfrm>
+            <a:off x="1280160" y="5349240"/>
+            <a:ext cx="9601200" cy="411480"/>
+          </a:xfrm>
+          <a:prstGeom prst="rect">
+            <a:avLst/>
+          </a:prstGeom>
+          <a:solidFill>
+            <a:srgbClr val="FFE600"/>
+          </a:solidFill>
+          <a:ln w="19050">
+            <a:solidFill>
+              <a:srgbClr val="000000"/>
+            </a:solidFill>
+          </a:ln>
+        </p:spPr>
+        <p:style>
+          <a:lnRef idx="1">
+            <a:schemeClr val="accent1"/>
+          </a:lnRef>
+          <a:fillRef idx="3">
+            <a:schemeClr val="accent1"/>
+          </a:fillRef>
+          <a:effectRef idx="2">
+            <a:schemeClr val="accent1"/>
+          </a:effectRef>
+          <a:fontRef idx="minor">
+            <a:schemeClr val="lt1"/>
+          </a:fontRef>
+        </p:style>
+        <p:txBody>
+          <a:bodyPr rtlCol="0" anchor="ctr"/>
+          <a:lstStyle/>
+          <a:p>
+            <a:pPr algn="ctr"/>
+          </a:p>
+        </p:txBody>
+      </p:sp>
+      <p:sp>
+        <p:nvSpPr>
+          <p:cNvPr id="7" name="TextBox 6"/>
+          <p:cNvSpPr txBox="1"/>
+          <p:nvPr/>
+        </p:nvSpPr>
+        <p:spPr>
+          <a:xfrm>
+            <a:off x="1280160" y="5349240"/>
+            <a:ext cx="9601200" cy="411480"/>
+          </a:xfrm>
+          <a:prstGeom prst="rect">
+            <a:avLst/>
+          </a:prstGeom>
+          <a:noFill/>
+        </p:spPr>
+        <p:txBody>
+          <a:bodyPr wrap="none">
+            <a:spAutoFit/>
+          </a:bodyPr>
+          <a:lstStyle/>
+          <a:p>
+            <a:pPr>
+              <a:defRPr sz="950" b="1">
+                <a:solidFill>
+                  <a:srgbClr val="000000"/>
+                </a:solidFill>
+                <a:latin typeface="Segoe UI"/>
+              </a:defRPr>
+            </a:pPr>
+            <a:r>
+              <a:t>▶ KLIK UNTUK MEMBUKA ROADMAP &amp; TAGIHAN TUGAS 1 (slide_01_roadmap_sesi_dan_tugas_1.html)</a:t>
             </a:r>
           </a:p>
         </p:txBody>
@@ -8629,7 +8712,7 @@
         <p:spPr>
           <a:xfrm>
             <a:off x="896112" y="1719072"/>
-            <a:ext cx="5120640" cy="2148840"/>
+            <a:ext cx="5120640" cy="1965960"/>
           </a:xfrm>
           <a:prstGeom prst="rect">
             <a:avLst/>
@@ -8672,7 +8755,7 @@
         <p:spPr>
           <a:xfrm>
             <a:off x="822960" y="1645920"/>
-            <a:ext cx="5120640" cy="2148840"/>
+            <a:ext cx="5120640" cy="1965960"/>
           </a:xfrm>
           <a:prstGeom prst="rect">
             <a:avLst/>
@@ -8798,7 +8881,7 @@
         <p:spPr>
           <a:xfrm>
             <a:off x="1005840" y="2240280"/>
-            <a:ext cx="4754880" cy="1463040"/>
+            <a:ext cx="4754880" cy="1280160"/>
           </a:xfrm>
           <a:prstGeom prst="rect">
             <a:avLst/>
@@ -8850,7 +8933,7 @@
         <p:spPr>
           <a:xfrm>
             <a:off x="6321247" y="1719072"/>
-            <a:ext cx="5120640" cy="2148840"/>
+            <a:ext cx="5120640" cy="1965960"/>
           </a:xfrm>
           <a:prstGeom prst="rect">
             <a:avLst/>
@@ -8893,7 +8976,7 @@
         <p:spPr>
           <a:xfrm>
             <a:off x="6248095" y="1645920"/>
-            <a:ext cx="5120640" cy="2148840"/>
+            <a:ext cx="5120640" cy="1965960"/>
           </a:xfrm>
           <a:prstGeom prst="rect">
             <a:avLst/>
@@ -9019,7 +9102,7 @@
         <p:spPr>
           <a:xfrm>
             <a:off x="6430975" y="2240280"/>
-            <a:ext cx="4754880" cy="1463040"/>
+            <a:ext cx="4754880" cy="1280160"/>
           </a:xfrm>
           <a:prstGeom prst="rect">
             <a:avLst/>
@@ -9070,8 +9153,8 @@
         </p:nvSpPr>
         <p:spPr>
           <a:xfrm>
-            <a:off x="896112" y="4096512"/>
-            <a:ext cx="5120640" cy="2148840"/>
+            <a:off x="896112" y="3867912"/>
+            <a:ext cx="5120640" cy="1965960"/>
           </a:xfrm>
           <a:prstGeom prst="rect">
             <a:avLst/>
@@ -9113,8 +9196,8 @@
         </p:nvSpPr>
         <p:spPr>
           <a:xfrm>
-            <a:off x="822960" y="4023360"/>
-            <a:ext cx="5120640" cy="2148840"/>
+            <a:off x="822960" y="3794760"/>
+            <a:ext cx="5120640" cy="1965960"/>
           </a:xfrm>
           <a:prstGeom prst="rect">
             <a:avLst/>
@@ -9158,7 +9241,7 @@
         </p:nvSpPr>
         <p:spPr>
           <a:xfrm>
-            <a:off x="1005840" y="4206240"/>
+            <a:off x="1005840" y="3977640"/>
             <a:ext cx="1645920" cy="365760"/>
           </a:xfrm>
           <a:prstGeom prst="rect">
@@ -9203,7 +9286,7 @@
         </p:nvSpPr>
         <p:spPr>
           <a:xfrm>
-            <a:off x="1005840" y="4206240"/>
+            <a:off x="1005840" y="3977640"/>
             <a:ext cx="1645920" cy="365760"/>
           </a:xfrm>
           <a:prstGeom prst="rect">
@@ -9239,8 +9322,8 @@
         </p:nvSpPr>
         <p:spPr>
           <a:xfrm>
-            <a:off x="1005840" y="4617720"/>
-            <a:ext cx="4754880" cy="1463040"/>
+            <a:off x="1005840" y="4389120"/>
+            <a:ext cx="4754880" cy="1280160"/>
           </a:xfrm>
           <a:prstGeom prst="rect">
             <a:avLst/>
@@ -9291,8 +9374,8 @@
         </p:nvSpPr>
         <p:spPr>
           <a:xfrm>
-            <a:off x="6321247" y="4096512"/>
-            <a:ext cx="5120640" cy="2148840"/>
+            <a:off x="6321247" y="3867912"/>
+            <a:ext cx="5120640" cy="1965960"/>
           </a:xfrm>
           <a:prstGeom prst="rect">
             <a:avLst/>
@@ -9334,8 +9417,8 @@
         </p:nvSpPr>
         <p:spPr>
           <a:xfrm>
-            <a:off x="6248095" y="4023360"/>
-            <a:ext cx="5120640" cy="2148840"/>
+            <a:off x="6248095" y="3794760"/>
+            <a:ext cx="5120640" cy="1965960"/>
           </a:xfrm>
           <a:prstGeom prst="rect">
             <a:avLst/>
@@ -9379,7 +9462,7 @@
         </p:nvSpPr>
         <p:spPr>
           <a:xfrm>
-            <a:off x="6430975" y="4206240"/>
+            <a:off x="6430975" y="3977640"/>
             <a:ext cx="1645920" cy="365760"/>
           </a:xfrm>
           <a:prstGeom prst="rect">
@@ -9424,7 +9507,7 @@
         </p:nvSpPr>
         <p:spPr>
           <a:xfrm>
-            <a:off x="6430975" y="4206240"/>
+            <a:off x="6430975" y="3977640"/>
             <a:ext cx="1645920" cy="365760"/>
           </a:xfrm>
           <a:prstGeom prst="rect">
@@ -9460,8 +9543,8 @@
         </p:nvSpPr>
         <p:spPr>
           <a:xfrm>
-            <a:off x="6430975" y="4617720"/>
-            <a:ext cx="4754880" cy="1463040"/>
+            <a:off x="6430975" y="4389120"/>
+            <a:ext cx="4754880" cy="1280160"/>
           </a:xfrm>
           <a:prstGeom prst="rect">
             <a:avLst/>
@@ -9500,6 +9583,89 @@
             </a:pPr>
             <a:r>
               <a:t>Menyertakan link video YouTube Unlisted (3-5 menit) demonstrasi aplikasi dan penjelasan kode dengan wajah mahasiswa. Bebas plagiasi.</a:t>
+            </a:r>
+          </a:p>
+        </p:txBody>
+      </p:sp>
+      <p:sp>
+        <p:nvSpPr>
+          <p:cNvPr id="27" name="Rectangle 26">
+            <a:hlinkClick r:id="rId2"/>
+          </p:cNvPr>
+          <p:cNvSpPr/>
+          <p:nvPr/>
+        </p:nvSpPr>
+        <p:spPr>
+          <a:xfrm>
+            <a:off x="822960" y="5989320"/>
+            <a:ext cx="10545775" cy="384048"/>
+          </a:xfrm>
+          <a:prstGeom prst="rect">
+            <a:avLst/>
+          </a:prstGeom>
+          <a:solidFill>
+            <a:srgbClr val="FFE600"/>
+          </a:solidFill>
+          <a:ln w="19050">
+            <a:solidFill>
+              <a:srgbClr val="000000"/>
+            </a:solidFill>
+          </a:ln>
+        </p:spPr>
+        <p:style>
+          <a:lnRef idx="1">
+            <a:schemeClr val="accent1"/>
+          </a:lnRef>
+          <a:fillRef idx="3">
+            <a:schemeClr val="accent1"/>
+          </a:fillRef>
+          <a:effectRef idx="2">
+            <a:schemeClr val="accent1"/>
+          </a:effectRef>
+          <a:fontRef idx="minor">
+            <a:schemeClr val="lt1"/>
+          </a:fontRef>
+        </p:style>
+        <p:txBody>
+          <a:bodyPr rtlCol="0" anchor="ctr"/>
+          <a:lstStyle/>
+          <a:p>
+            <a:pPr algn="ctr"/>
+          </a:p>
+        </p:txBody>
+      </p:sp>
+      <p:sp>
+        <p:nvSpPr>
+          <p:cNvPr id="28" name="TextBox 27"/>
+          <p:cNvSpPr txBox="1"/>
+          <p:nvPr/>
+        </p:nvSpPr>
+        <p:spPr>
+          <a:xfrm>
+            <a:off x="822960" y="5989320"/>
+            <a:ext cx="10545775" cy="384048"/>
+          </a:xfrm>
+          <a:prstGeom prst="rect">
+            <a:avLst/>
+          </a:prstGeom>
+          <a:noFill/>
+        </p:spPr>
+        <p:txBody>
+          <a:bodyPr wrap="none">
+            <a:spAutoFit/>
+          </a:bodyPr>
+          <a:lstStyle/>
+          <a:p>
+            <a:pPr>
+              <a:defRPr sz="950" b="1">
+                <a:solidFill>
+                  <a:srgbClr val="000000"/>
+                </a:solidFill>
+                <a:latin typeface="Segoe UI"/>
+              </a:defRPr>
+            </a:pPr>
+            <a:r>
+              <a:t>▶ KLIK UNTUK MEMBUKA KALKULATOR RUBRIK INTERAKTIF (slide_16_rubrik_tugas_tutorial_1.html)</a:t>
             </a:r>
           </a:p>
         </p:txBody>
@@ -10581,7 +10747,7 @@
         <p:spPr>
           <a:xfrm>
             <a:off x="896112" y="1719072"/>
-            <a:ext cx="5120640" cy="4663440"/>
+            <a:ext cx="5120640" cy="4160520"/>
           </a:xfrm>
           <a:prstGeom prst="rect">
             <a:avLst/>
@@ -10624,7 +10790,7 @@
         <p:spPr>
           <a:xfrm>
             <a:off x="822960" y="1645920"/>
-            <a:ext cx="5120640" cy="4663440"/>
+            <a:ext cx="5120640" cy="4160520"/>
           </a:xfrm>
           <a:prstGeom prst="rect">
             <a:avLst/>
@@ -10750,7 +10916,7 @@
         <p:spPr>
           <a:xfrm>
             <a:off x="1051560" y="2468880"/>
-            <a:ext cx="4663440" cy="3657600"/>
+            <a:ext cx="4663440" cy="3291840"/>
           </a:xfrm>
           <a:prstGeom prst="rect">
             <a:avLst/>
@@ -10765,7 +10931,7 @@
           <a:p>
             <a:pPr>
               <a:spcAft>
-                <a:spcPts val="800"/>
+                <a:spcPts val="600"/>
               </a:spcAft>
               <a:defRPr sz="1100">
                 <a:latin typeface="Segoe UI"/>
@@ -10778,7 +10944,7 @@
           <a:p>
             <a:pPr>
               <a:spcAft>
-                <a:spcPts val="800"/>
+                <a:spcPts val="600"/>
               </a:spcAft>
               <a:defRPr sz="1100">
                 <a:latin typeface="Segoe UI"/>
@@ -10791,7 +10957,7 @@
           <a:p>
             <a:pPr>
               <a:spcAft>
-                <a:spcPts val="800"/>
+                <a:spcPts val="600"/>
               </a:spcAft>
               <a:defRPr sz="1100">
                 <a:latin typeface="Segoe UI"/>
@@ -10804,7 +10970,7 @@
           <a:p>
             <a:pPr>
               <a:spcAft>
-                <a:spcPts val="800"/>
+                <a:spcPts val="600"/>
               </a:spcAft>
               <a:defRPr sz="1100">
                 <a:latin typeface="Segoe UI"/>
@@ -10817,7 +10983,7 @@
           <a:p>
             <a:pPr>
               <a:spcAft>
-                <a:spcPts val="800"/>
+                <a:spcPts val="600"/>
               </a:spcAft>
               <a:defRPr sz="1100">
                 <a:latin typeface="Segoe UI"/>
@@ -10838,7 +11004,7 @@
         <p:spPr>
           <a:xfrm>
             <a:off x="6321247" y="1719072"/>
-            <a:ext cx="5120640" cy="4663440"/>
+            <a:ext cx="5120640" cy="4160520"/>
           </a:xfrm>
           <a:prstGeom prst="rect">
             <a:avLst/>
@@ -10881,7 +11047,7 @@
         <p:spPr>
           <a:xfrm>
             <a:off x="6248095" y="1645920"/>
-            <a:ext cx="5120640" cy="4663440"/>
+            <a:ext cx="5120640" cy="4160520"/>
           </a:xfrm>
           <a:prstGeom prst="rect">
             <a:avLst/>
@@ -11007,7 +11173,7 @@
         <p:spPr>
           <a:xfrm>
             <a:off x="6476695" y="2468880"/>
-            <a:ext cx="4663440" cy="3657600"/>
+            <a:ext cx="4663440" cy="3291840"/>
           </a:xfrm>
           <a:prstGeom prst="rect">
             <a:avLst/>
@@ -11022,7 +11188,7 @@
           <a:p>
             <a:pPr>
               <a:spcAft>
-                <a:spcPts val="800"/>
+                <a:spcPts val="600"/>
               </a:spcAft>
               <a:defRPr sz="1100">
                 <a:latin typeface="Segoe UI"/>
@@ -11035,7 +11201,7 @@
           <a:p>
             <a:pPr>
               <a:spcAft>
-                <a:spcPts val="800"/>
+                <a:spcPts val="600"/>
               </a:spcAft>
               <a:defRPr sz="1100">
                 <a:latin typeface="Segoe UI"/>
@@ -11048,7 +11214,7 @@
           <a:p>
             <a:pPr>
               <a:spcAft>
-                <a:spcPts val="800"/>
+                <a:spcPts val="600"/>
               </a:spcAft>
               <a:defRPr sz="1100">
                 <a:latin typeface="Segoe UI"/>
@@ -11061,7 +11227,7 @@
           <a:p>
             <a:pPr>
               <a:spcAft>
-                <a:spcPts val="800"/>
+                <a:spcPts val="600"/>
               </a:spcAft>
               <a:defRPr sz="1100">
                 <a:latin typeface="Segoe UI"/>
@@ -11074,7 +11240,7 @@
           <a:p>
             <a:pPr>
               <a:spcAft>
-                <a:spcPts val="800"/>
+                <a:spcPts val="600"/>
               </a:spcAft>
               <a:defRPr sz="1100">
                 <a:latin typeface="Segoe UI"/>
@@ -11082,6 +11248,89 @@
             </a:pPr>
             <a:r>
               <a:t>■  Langkah awal membangun APK Android asli di perkuliahan kita!</a:t>
+            </a:r>
+          </a:p>
+        </p:txBody>
+      </p:sp>
+      <p:sp>
+        <p:nvSpPr>
+          <p:cNvPr id="17" name="Rectangle 16">
+            <a:hlinkClick r:id="rId2"/>
+          </p:cNvPr>
+          <p:cNvSpPr/>
+          <p:nvPr/>
+        </p:nvSpPr>
+        <p:spPr>
+          <a:xfrm>
+            <a:off x="822960" y="5989320"/>
+            <a:ext cx="10545775" cy="384048"/>
+          </a:xfrm>
+          <a:prstGeom prst="rect">
+            <a:avLst/>
+          </a:prstGeom>
+          <a:solidFill>
+            <a:srgbClr val="FFE600"/>
+          </a:solidFill>
+          <a:ln w="19050">
+            <a:solidFill>
+              <a:srgbClr val="000000"/>
+            </a:solidFill>
+          </a:ln>
+        </p:spPr>
+        <p:style>
+          <a:lnRef idx="1">
+            <a:schemeClr val="accent1"/>
+          </a:lnRef>
+          <a:fillRef idx="3">
+            <a:schemeClr val="accent1"/>
+          </a:fillRef>
+          <a:effectRef idx="2">
+            <a:schemeClr val="accent1"/>
+          </a:effectRef>
+          <a:fontRef idx="minor">
+            <a:schemeClr val="lt1"/>
+          </a:fontRef>
+        </p:style>
+        <p:txBody>
+          <a:bodyPr rtlCol="0" anchor="ctr"/>
+          <a:lstStyle/>
+          <a:p>
+            <a:pPr algn="ctr"/>
+          </a:p>
+        </p:txBody>
+      </p:sp>
+      <p:sp>
+        <p:nvSpPr>
+          <p:cNvPr id="18" name="TextBox 17"/>
+          <p:cNvSpPr txBox="1"/>
+          <p:nvPr/>
+        </p:nvSpPr>
+        <p:spPr>
+          <a:xfrm>
+            <a:off x="822960" y="5989320"/>
+            <a:ext cx="10545775" cy="384048"/>
+          </a:xfrm>
+          <a:prstGeom prst="rect">
+            <a:avLst/>
+          </a:prstGeom>
+          <a:noFill/>
+        </p:spPr>
+        <p:txBody>
+          <a:bodyPr wrap="none">
+            <a:spAutoFit/>
+          </a:bodyPr>
+          <a:lstStyle/>
+          <a:p>
+            <a:pPr>
+              <a:defRPr sz="950" b="1">
+                <a:solidFill>
+                  <a:srgbClr val="000000"/>
+                </a:solidFill>
+                <a:latin typeface="Segoe UI"/>
+              </a:defRPr>
+            </a:pPr>
+            <a:r>
+              <a:t>▶ KLIK UNTUK MEMBUKA KODE LENGKAP (slide_18_preview_sesi_04_ionic_ui.html)</a:t>
             </a:r>
           </a:p>
         </p:txBody>
@@ -11316,7 +11565,7 @@
         <p:spPr>
           <a:xfrm>
             <a:off x="896112" y="1719072"/>
-            <a:ext cx="5120640" cy="4663440"/>
+            <a:ext cx="5120640" cy="4160520"/>
           </a:xfrm>
           <a:prstGeom prst="rect">
             <a:avLst/>
@@ -11359,7 +11608,7 @@
         <p:spPr>
           <a:xfrm>
             <a:off x="822960" y="1645920"/>
-            <a:ext cx="5120640" cy="4663440"/>
+            <a:ext cx="5120640" cy="4160520"/>
           </a:xfrm>
           <a:prstGeom prst="rect">
             <a:avLst/>
@@ -11485,7 +11734,7 @@
         <p:spPr>
           <a:xfrm>
             <a:off x="1051560" y="2468880"/>
-            <a:ext cx="4663440" cy="3657600"/>
+            <a:ext cx="4663440" cy="3291840"/>
           </a:xfrm>
           <a:prstGeom prst="rect">
             <a:avLst/>
@@ -11500,7 +11749,7 @@
           <a:p>
             <a:pPr>
               <a:spcAft>
-                <a:spcPts val="800"/>
+                <a:spcPts val="600"/>
               </a:spcAft>
               <a:defRPr sz="1100">
                 <a:latin typeface="Segoe UI"/>
@@ -11513,7 +11762,7 @@
           <a:p>
             <a:pPr>
               <a:spcAft>
-                <a:spcPts val="800"/>
+                <a:spcPts val="600"/>
               </a:spcAft>
               <a:defRPr sz="1100">
                 <a:latin typeface="Segoe UI"/>
@@ -11526,7 +11775,7 @@
           <a:p>
             <a:pPr>
               <a:spcAft>
-                <a:spcPts val="800"/>
+                <a:spcPts val="600"/>
               </a:spcAft>
               <a:defRPr sz="1100">
                 <a:latin typeface="Segoe UI"/>
@@ -11539,7 +11788,7 @@
           <a:p>
             <a:pPr>
               <a:spcAft>
-                <a:spcPts val="800"/>
+                <a:spcPts val="600"/>
               </a:spcAft>
               <a:defRPr sz="1100">
                 <a:latin typeface="Segoe UI"/>
@@ -11552,7 +11801,7 @@
           <a:p>
             <a:pPr>
               <a:spcAft>
-                <a:spcPts val="800"/>
+                <a:spcPts val="600"/>
               </a:spcAft>
               <a:defRPr sz="1100">
                 <a:latin typeface="Segoe UI"/>
@@ -11573,7 +11822,7 @@
         <p:spPr>
           <a:xfrm>
             <a:off x="6321247" y="1719072"/>
-            <a:ext cx="5120640" cy="4663440"/>
+            <a:ext cx="5120640" cy="4160520"/>
           </a:xfrm>
           <a:prstGeom prst="rect">
             <a:avLst/>
@@ -11616,7 +11865,7 @@
         <p:spPr>
           <a:xfrm>
             <a:off x="6248095" y="1645920"/>
-            <a:ext cx="5120640" cy="4663440"/>
+            <a:ext cx="5120640" cy="4160520"/>
           </a:xfrm>
           <a:prstGeom prst="rect">
             <a:avLst/>
@@ -11742,7 +11991,7 @@
         <p:spPr>
           <a:xfrm>
             <a:off x="6476695" y="2468880"/>
-            <a:ext cx="4663440" cy="3657600"/>
+            <a:ext cx="4663440" cy="3291840"/>
           </a:xfrm>
           <a:prstGeom prst="rect">
             <a:avLst/>
@@ -11757,7 +12006,7 @@
           <a:p>
             <a:pPr>
               <a:spcAft>
-                <a:spcPts val="800"/>
+                <a:spcPts val="600"/>
               </a:spcAft>
               <a:defRPr sz="1100">
                 <a:latin typeface="Segoe UI"/>
@@ -11770,7 +12019,7 @@
           <a:p>
             <a:pPr>
               <a:spcAft>
-                <a:spcPts val="800"/>
+                <a:spcPts val="600"/>
               </a:spcAft>
               <a:defRPr sz="1100">
                 <a:latin typeface="Segoe UI"/>
@@ -11783,7 +12032,7 @@
           <a:p>
             <a:pPr>
               <a:spcAft>
-                <a:spcPts val="800"/>
+                <a:spcPts val="600"/>
               </a:spcAft>
               <a:defRPr sz="1100">
                 <a:latin typeface="Segoe UI"/>
@@ -11796,7 +12045,7 @@
           <a:p>
             <a:pPr>
               <a:spcAft>
-                <a:spcPts val="800"/>
+                <a:spcPts val="600"/>
               </a:spcAft>
               <a:defRPr sz="1100">
                 <a:latin typeface="Segoe UI"/>
@@ -11809,7 +12058,7 @@
           <a:p>
             <a:pPr>
               <a:spcAft>
-                <a:spcPts val="800"/>
+                <a:spcPts val="600"/>
               </a:spcAft>
               <a:defRPr sz="1100">
                 <a:latin typeface="Segoe UI"/>
@@ -11817,6 +12066,89 @@
             </a:pPr>
             <a:r>
               <a:t>■  Fondasi wajib untuk menyelesaikan TUGAS TUTORIAL 1 secara presisi.</a:t>
+            </a:r>
+          </a:p>
+        </p:txBody>
+      </p:sp>
+      <p:sp>
+        <p:nvSpPr>
+          <p:cNvPr id="17" name="Rectangle 16">
+            <a:hlinkClick r:id="rId2"/>
+          </p:cNvPr>
+          <p:cNvSpPr/>
+          <p:nvPr/>
+        </p:nvSpPr>
+        <p:spPr>
+          <a:xfrm>
+            <a:off x="822960" y="5989320"/>
+            <a:ext cx="10545775" cy="384048"/>
+          </a:xfrm>
+          <a:prstGeom prst="rect">
+            <a:avLst/>
+          </a:prstGeom>
+          <a:solidFill>
+            <a:srgbClr val="FFE600"/>
+          </a:solidFill>
+          <a:ln w="19050">
+            <a:solidFill>
+              <a:srgbClr val="000000"/>
+            </a:solidFill>
+          </a:ln>
+        </p:spPr>
+        <p:style>
+          <a:lnRef idx="1">
+            <a:schemeClr val="accent1"/>
+          </a:lnRef>
+          <a:fillRef idx="3">
+            <a:schemeClr val="accent1"/>
+          </a:fillRef>
+          <a:effectRef idx="2">
+            <a:schemeClr val="accent1"/>
+          </a:effectRef>
+          <a:fontRef idx="minor">
+            <a:schemeClr val="lt1"/>
+          </a:fontRef>
+        </p:style>
+        <p:txBody>
+          <a:bodyPr rtlCol="0" anchor="ctr"/>
+          <a:lstStyle/>
+          <a:p>
+            <a:pPr algn="ctr"/>
+          </a:p>
+        </p:txBody>
+      </p:sp>
+      <p:sp>
+        <p:nvSpPr>
+          <p:cNvPr id="18" name="TextBox 17"/>
+          <p:cNvSpPr txBox="1"/>
+          <p:nvPr/>
+        </p:nvSpPr>
+        <p:spPr>
+          <a:xfrm>
+            <a:off x="822960" y="5989320"/>
+            <a:ext cx="10545775" cy="384048"/>
+          </a:xfrm>
+          <a:prstGeom prst="rect">
+            <a:avLst/>
+          </a:prstGeom>
+          <a:noFill/>
+        </p:spPr>
+        <p:txBody>
+          <a:bodyPr wrap="none">
+            <a:spAutoFit/>
+          </a:bodyPr>
+          <a:lstStyle/>
+          <a:p>
+            <a:pPr>
+              <a:defRPr sz="950" b="1">
+                <a:solidFill>
+                  <a:srgbClr val="000000"/>
+                </a:solidFill>
+                <a:latin typeface="Segoe UI"/>
+              </a:defRPr>
+            </a:pPr>
+            <a:r>
+              <a:t>▶ KLIK UNTUK MEMBUKA KODE LENGKAP (slide_02_urgensi_typescript_mobile.html)</a:t>
             </a:r>
           </a:p>
         </p:txBody>
@@ -14357,7 +14689,7 @@
               </a:defRPr>
             </a:pPr>
             <a:r>
-              <a:t>▶ KLIK UNTUK MEMBUKA KODE LENGKAP (slide_05_interface_model_mahasiswa.ts)</a:t>
+              <a:t>▶ KLIK UNTUK MEMBUKA KODE LENGKAP (slide_05_interface_model_mahasiswa.html)</a:t>
             </a:r>
           </a:p>
         </p:txBody>

</xml_diff>

<commit_message>
feat(sesi-03): sempurnakan slide 01 pptx dengan kartu komparasi visual roadmap dan tugas 1
</commit_message>
<xml_diff>
--- a/slide_presentasi/SESI_03_TypeScript_dan_Komposisi_Vue.pptx
+++ b/slide_presentasi/SESI_03_TypeScript_dan_Komposisi_Vue.pptx
@@ -3156,8 +3156,8 @@
         </p:nvSpPr>
         <p:spPr>
           <a:xfrm>
-            <a:off x="896112" y="896112"/>
-            <a:ext cx="10545775" cy="5212080"/>
+            <a:off x="896112" y="530352"/>
+            <a:ext cx="10545775" cy="5897880"/>
           </a:xfrm>
           <a:prstGeom prst="rect">
             <a:avLst/>
@@ -3199,8 +3199,8 @@
         </p:nvSpPr>
         <p:spPr>
           <a:xfrm>
-            <a:off x="822960" y="822960"/>
-            <a:ext cx="10545775" cy="5212080"/>
+            <a:off x="822960" y="457200"/>
+            <a:ext cx="10545775" cy="5897880"/>
           </a:xfrm>
           <a:prstGeom prst="rect">
             <a:avLst/>
@@ -3244,8 +3244,8 @@
         </p:nvSpPr>
         <p:spPr>
           <a:xfrm>
-            <a:off x="1280160" y="1188720"/>
-            <a:ext cx="9601200" cy="3931920"/>
+            <a:off x="1097280" y="594360"/>
+            <a:ext cx="9997135" cy="1371600"/>
           </a:xfrm>
           <a:prstGeom prst="rect">
             <a:avLst/>
@@ -3260,9 +3260,9 @@
           <a:p>
             <a:pPr>
               <a:spcAft>
-                <a:spcPts val="1600"/>
+                <a:spcPts val="400"/>
               </a:spcAft>
-              <a:defRPr sz="1200" b="1">
+              <a:defRPr sz="1100" b="1">
                 <a:solidFill>
                   <a:srgbClr val="000000"/>
                 </a:solidFill>
@@ -3276,9 +3276,9 @@
           <a:p>
             <a:pPr>
               <a:spcAft>
-                <a:spcPts val="1400"/>
+                <a:spcPts val="400"/>
               </a:spcAft>
-              <a:defRPr sz="2600" b="1">
+              <a:defRPr sz="2200" b="1">
                 <a:solidFill>
                   <a:srgbClr val="000000"/>
                 </a:solidFill>
@@ -3291,12 +3291,9 @@
           </a:p>
           <a:p>
             <a:pPr>
-              <a:spcAft>
-                <a:spcPts val="2600"/>
-              </a:spcAft>
-              <a:defRPr sz="1350">
-                <a:solidFill>
-                  <a:srgbClr val="3C3C3C"/>
+              <a:defRPr sz="1050">
+                <a:solidFill>
+                  <a:srgbClr val="464646"/>
                 </a:solidFill>
                 <a:latin typeface="Segoe UI"/>
               </a:defRPr>
@@ -3309,44 +3306,27 @@
               <a:t>Modul Acuan BMP: Modul 3 • Type Safety, Interface, Generics, &amp; Bedah Kasus TUGAS TUTORIAL 1</a:t>
             </a:r>
           </a:p>
-          <a:p>
-            <a:pPr>
-              <a:defRPr sz="1150" b="1">
-                <a:solidFill>
-                  <a:srgbClr val="000000"/>
-                </a:solidFill>
-                <a:latin typeface="Segoe UI"/>
-              </a:defRPr>
-            </a:pPr>
-            <a:r>
-              <a:t>■  Anton Prafanto, S.Kom., M.T.  ■  FAKULTAS SAINS DAN TEKNOLOGI • UNIVERSITAS TERBUKA</a:t>
-            </a:r>
-          </a:p>
-        </p:txBody>
-      </p:sp>
-      <p:sp>
-        <p:nvSpPr>
-          <p:cNvPr id="6" name="Rectangle 5">
-            <a:hlinkClick r:id="rId2"/>
-          </p:cNvPr>
+        </p:txBody>
+      </p:sp>
+      <p:sp>
+        <p:nvSpPr>
+          <p:cNvPr id="6" name="Rectangle 5"/>
           <p:cNvSpPr/>
           <p:nvPr/>
         </p:nvSpPr>
         <p:spPr>
           <a:xfrm>
-            <a:off x="1280160" y="5349240"/>
-            <a:ext cx="9601200" cy="411480"/>
+            <a:off x="1170432" y="2130552"/>
+            <a:ext cx="4864608" cy="2468880"/>
           </a:xfrm>
           <a:prstGeom prst="rect">
             <a:avLst/>
           </a:prstGeom>
           <a:solidFill>
-            <a:srgbClr val="FFE600"/>
+            <a:srgbClr val="000000"/>
           </a:solidFill>
-          <a:ln w="19050">
-            <a:solidFill>
-              <a:srgbClr val="000000"/>
-            </a:solidFill>
+          <a:ln>
+            <a:noFill/>
           </a:ln>
         </p:spPr>
         <p:style>
@@ -3373,14 +3353,425 @@
       </p:sp>
       <p:sp>
         <p:nvSpPr>
-          <p:cNvPr id="7" name="TextBox 6"/>
+          <p:cNvPr id="7" name="Rectangle 6"/>
+          <p:cNvSpPr/>
+          <p:nvPr/>
+        </p:nvSpPr>
+        <p:spPr>
+          <a:xfrm>
+            <a:off x="1097280" y="2057400"/>
+            <a:ext cx="4864608" cy="2468880"/>
+          </a:xfrm>
+          <a:prstGeom prst="rect">
+            <a:avLst/>
+          </a:prstGeom>
+          <a:solidFill>
+            <a:srgbClr val="F5F3FF"/>
+          </a:solidFill>
+          <a:ln w="31750">
+            <a:solidFill>
+              <a:srgbClr val="000000"/>
+            </a:solidFill>
+          </a:ln>
+        </p:spPr>
+        <p:style>
+          <a:lnRef idx="1">
+            <a:schemeClr val="accent1"/>
+          </a:lnRef>
+          <a:fillRef idx="3">
+            <a:schemeClr val="accent1"/>
+          </a:fillRef>
+          <a:effectRef idx="2">
+            <a:schemeClr val="accent1"/>
+          </a:effectRef>
+          <a:fontRef idx="minor">
+            <a:schemeClr val="lt1"/>
+          </a:fontRef>
+        </p:style>
+        <p:txBody>
+          <a:bodyPr rtlCol="0" anchor="ctr"/>
+          <a:lstStyle/>
+          <a:p>
+            <a:pPr algn="ctr"/>
+          </a:p>
+        </p:txBody>
+      </p:sp>
+      <p:sp>
+        <p:nvSpPr>
+          <p:cNvPr id="8" name="TextBox 7"/>
           <p:cNvSpPr txBox="1"/>
           <p:nvPr/>
         </p:nvSpPr>
         <p:spPr>
           <a:xfrm>
-            <a:off x="1280160" y="5349240"/>
-            <a:ext cx="9601200" cy="411480"/>
+            <a:off x="1280160" y="2194560"/>
+            <a:ext cx="4498848" cy="2194560"/>
+          </a:xfrm>
+          <a:prstGeom prst="rect">
+            <a:avLst/>
+          </a:prstGeom>
+          <a:noFill/>
+        </p:spPr>
+        <p:txBody>
+          <a:bodyPr wrap="square">
+            <a:spAutoFit/>
+          </a:bodyPr>
+          <a:lstStyle/>
+          <a:p>
+            <a:pPr>
+              <a:spcAft>
+                <a:spcPts val="800"/>
+              </a:spcAft>
+              <a:defRPr sz="1200" b="1">
+                <a:solidFill>
+                  <a:srgbClr val="6D28D9"/>
+                </a:solidFill>
+                <a:latin typeface="Segoe UI"/>
+              </a:defRPr>
+            </a:pPr>
+            <a:r>
+              <a:t>🗺️ ROADMAP KURIKULUM &amp; SESI 03</a:t>
+            </a:r>
+          </a:p>
+          <a:p>
+            <a:pPr>
+              <a:spcAft>
+                <a:spcPts val="400"/>
+              </a:spcAft>
+            </a:pPr>
+            <a:r>
+              <a:rPr sz="950" b="1">
+                <a:solidFill>
+                  <a:srgbClr val="000000"/>
+                </a:solidFill>
+                <a:latin typeface="Segoe UI"/>
+              </a:rPr>
+              <a:t>• Milestone 1 STSI4303:</a:t>
+            </a:r>
+            <a:r>
+              <a:rPr sz="950">
+                <a:solidFill>
+                  <a:srgbClr val="323232"/>
+                </a:solidFill>
+                <a:latin typeface="Segoe UI"/>
+              </a:rPr>
+              <a:t> Titik tolak evaluasi mandiri pertama setelah fondasi Vue Sesi 1-2.</a:t>
+            </a:r>
+          </a:p>
+          <a:p>
+            <a:pPr>
+              <a:spcAft>
+                <a:spcPts val="400"/>
+              </a:spcAft>
+            </a:pPr>
+            <a:r>
+              <a:rPr sz="950" b="1">
+                <a:solidFill>
+                  <a:srgbClr val="000000"/>
+                </a:solidFill>
+                <a:latin typeface="Segoe UI"/>
+              </a:rPr>
+              <a:t>• Type Safety Mobile:</a:t>
+            </a:r>
+            <a:r>
+              <a:rPr sz="950">
+                <a:solidFill>
+                  <a:srgbClr val="323232"/>
+                </a:solidFill>
+                <a:latin typeface="Segoe UI"/>
+              </a:rPr>
+              <a:t> Mengeliminasi galat runtime crash di smartphone sebelum aplikasi dirilis.</a:t>
+            </a:r>
+          </a:p>
+          <a:p>
+            <a:pPr>
+              <a:spcAft>
+                <a:spcPts val="400"/>
+              </a:spcAft>
+            </a:pPr>
+            <a:r>
+              <a:rPr sz="950" b="1">
+                <a:solidFill>
+                  <a:srgbClr val="000000"/>
+                </a:solidFill>
+                <a:latin typeface="Segoe UI"/>
+              </a:rPr>
+              <a:t>• Vue 3 Composition API:</a:t>
+            </a:r>
+            <a:r>
+              <a:rPr sz="950">
+                <a:solidFill>
+                  <a:srgbClr val="323232"/>
+                </a:solidFill>
+                <a:latin typeface="Segoe UI"/>
+              </a:rPr>
+              <a:t> Integrasi &lt;script setup lang='ts'&gt; dengan ref, reactive, dan computed.</a:t>
+            </a:r>
+          </a:p>
+          <a:p>
+            <a:pPr>
+              <a:spcAft>
+                <a:spcPts val="400"/>
+              </a:spcAft>
+            </a:pPr>
+            <a:r>
+              <a:rPr sz="950" b="1">
+                <a:solidFill>
+                  <a:srgbClr val="000000"/>
+                </a:solidFill>
+                <a:latin typeface="Segoe UI"/>
+              </a:rPr>
+              <a:t>• Prinsip Zero-Friction:</a:t>
+            </a:r>
+            <a:r>
+              <a:rPr sz="950">
+                <a:solidFill>
+                  <a:srgbClr val="323232"/>
+                </a:solidFill>
+                <a:latin typeface="Segoe UI"/>
+              </a:rPr>
+              <a:t> 18 berkas mandiri HTML siap klik 2x langsung jalan di browser Google Chrome.</a:t>
+            </a:r>
+          </a:p>
+        </p:txBody>
+      </p:sp>
+      <p:sp>
+        <p:nvSpPr>
+          <p:cNvPr id="9" name="Rectangle 8"/>
+          <p:cNvSpPr/>
+          <p:nvPr/>
+        </p:nvSpPr>
+        <p:spPr>
+          <a:xfrm>
+            <a:off x="6300216" y="2130552"/>
+            <a:ext cx="4864608" cy="2468880"/>
+          </a:xfrm>
+          <a:prstGeom prst="rect">
+            <a:avLst/>
+          </a:prstGeom>
+          <a:solidFill>
+            <a:srgbClr val="000000"/>
+          </a:solidFill>
+          <a:ln>
+            <a:noFill/>
+          </a:ln>
+        </p:spPr>
+        <p:style>
+          <a:lnRef idx="1">
+            <a:schemeClr val="accent1"/>
+          </a:lnRef>
+          <a:fillRef idx="3">
+            <a:schemeClr val="accent1"/>
+          </a:fillRef>
+          <a:effectRef idx="2">
+            <a:schemeClr val="accent1"/>
+          </a:effectRef>
+          <a:fontRef idx="minor">
+            <a:schemeClr val="lt1"/>
+          </a:fontRef>
+        </p:style>
+        <p:txBody>
+          <a:bodyPr rtlCol="0" anchor="ctr"/>
+          <a:lstStyle/>
+          <a:p>
+            <a:pPr algn="ctr"/>
+          </a:p>
+        </p:txBody>
+      </p:sp>
+      <p:sp>
+        <p:nvSpPr>
+          <p:cNvPr id="10" name="Rectangle 9"/>
+          <p:cNvSpPr/>
+          <p:nvPr/>
+        </p:nvSpPr>
+        <p:spPr>
+          <a:xfrm>
+            <a:off x="6227064" y="2057400"/>
+            <a:ext cx="4864608" cy="2468880"/>
+          </a:xfrm>
+          <a:prstGeom prst="rect">
+            <a:avLst/>
+          </a:prstGeom>
+          <a:solidFill>
+            <a:srgbClr val="4ADE80"/>
+          </a:solidFill>
+          <a:ln w="31750">
+            <a:solidFill>
+              <a:srgbClr val="000000"/>
+            </a:solidFill>
+          </a:ln>
+        </p:spPr>
+        <p:style>
+          <a:lnRef idx="1">
+            <a:schemeClr val="accent1"/>
+          </a:lnRef>
+          <a:fillRef idx="3">
+            <a:schemeClr val="accent1"/>
+          </a:fillRef>
+          <a:effectRef idx="2">
+            <a:schemeClr val="accent1"/>
+          </a:effectRef>
+          <a:fontRef idx="minor">
+            <a:schemeClr val="lt1"/>
+          </a:fontRef>
+        </p:style>
+        <p:txBody>
+          <a:bodyPr rtlCol="0" anchor="ctr"/>
+          <a:lstStyle/>
+          <a:p>
+            <a:pPr algn="ctr"/>
+          </a:p>
+        </p:txBody>
+      </p:sp>
+      <p:sp>
+        <p:nvSpPr>
+          <p:cNvPr id="11" name="TextBox 10"/>
+          <p:cNvSpPr txBox="1"/>
+          <p:nvPr/>
+        </p:nvSpPr>
+        <p:spPr>
+          <a:xfrm>
+            <a:off x="6409944" y="2194560"/>
+            <a:ext cx="4498848" cy="2194560"/>
+          </a:xfrm>
+          <a:prstGeom prst="rect">
+            <a:avLst/>
+          </a:prstGeom>
+          <a:noFill/>
+        </p:spPr>
+        <p:txBody>
+          <a:bodyPr wrap="square">
+            <a:spAutoFit/>
+          </a:bodyPr>
+          <a:lstStyle/>
+          <a:p>
+            <a:pPr>
+              <a:spcAft>
+                <a:spcPts val="800"/>
+              </a:spcAft>
+              <a:defRPr sz="1200" b="1">
+                <a:solidFill>
+                  <a:srgbClr val="15803D"/>
+                </a:solidFill>
+                <a:latin typeface="Segoe UI"/>
+              </a:defRPr>
+            </a:pPr>
+            <a:r>
+              <a:t>🎯 ORIENTASI TAGIHAN TUGAS TUTORIAL 1</a:t>
+            </a:r>
+          </a:p>
+          <a:p>
+            <a:pPr>
+              <a:spcAft>
+                <a:spcPts val="400"/>
+              </a:spcAft>
+            </a:pPr>
+            <a:r>
+              <a:rPr sz="950" b="1">
+                <a:solidFill>
+                  <a:srgbClr val="000000"/>
+                </a:solidFill>
+                <a:latin typeface="Segoe UI"/>
+              </a:rPr>
+              <a:t>• Bobot Penilaian Besar:</a:t>
+            </a:r>
+            <a:r>
+              <a:rPr sz="950">
+                <a:solidFill>
+                  <a:srgbClr val="323232"/>
+                </a:solidFill>
+                <a:latin typeface="Segoe UI"/>
+              </a:rPr>
+              <a:t> Berkontribusi dominan terhadap 70% nilai akhir tutorial semester.</a:t>
+            </a:r>
+          </a:p>
+          <a:p>
+            <a:pPr>
+              <a:spcAft>
+                <a:spcPts val="400"/>
+              </a:spcAft>
+            </a:pPr>
+            <a:r>
+              <a:rPr sz="950" b="1">
+                <a:solidFill>
+                  <a:srgbClr val="000000"/>
+                </a:solidFill>
+                <a:latin typeface="Segoe UI"/>
+              </a:rPr>
+              <a:t>• Studi Kasus Kalkulator UT:</a:t>
+            </a:r>
+            <a:r>
+              <a:rPr sz="950">
+                <a:solidFill>
+                  <a:srgbClr val="323232"/>
+                </a:solidFill>
+                <a:latin typeface="Segoe UI"/>
+              </a:rPr>
+              <a:t> Aplikasi hitung total SKS, konversi huruf ke mutu, dan prediksi IPS.</a:t>
+            </a:r>
+          </a:p>
+          <a:p>
+            <a:pPr>
+              <a:spcAft>
+                <a:spcPts val="400"/>
+              </a:spcAft>
+            </a:pPr>
+            <a:r>
+              <a:rPr sz="950" b="1">
+                <a:solidFill>
+                  <a:srgbClr val="000000"/>
+                </a:solidFill>
+                <a:latin typeface="Segoe UI"/>
+              </a:rPr>
+              <a:t>• 4 Pilar Rubrik FST UT:</a:t>
+            </a:r>
+            <a:r>
+              <a:rPr sz="950">
+                <a:solidFill>
+                  <a:srgbClr val="323232"/>
+                </a:solidFill>
+                <a:latin typeface="Segoe UI"/>
+              </a:rPr>
+              <a:t> Model TS (25%), Reaktivitas (25%), Logika IPS (30%), Video YouTube (20%).</a:t>
+            </a:r>
+          </a:p>
+          <a:p>
+            <a:pPr>
+              <a:spcAft>
+                <a:spcPts val="400"/>
+              </a:spcAft>
+            </a:pPr>
+            <a:r>
+              <a:rPr sz="950" b="1">
+                <a:solidFill>
+                  <a:srgbClr val="000000"/>
+                </a:solidFill>
+                <a:latin typeface="Segoe UI"/>
+              </a:rPr>
+              <a:t>• Master Solusi Resmi:</a:t>
+            </a:r>
+            <a:r>
+              <a:rPr sz="950">
+                <a:solidFill>
+                  <a:srgbClr val="323232"/>
+                </a:solidFill>
+                <a:latin typeface="Segoe UI"/>
+              </a:rPr>
+              <a:t> Disediakan acuan lengkap di slide_17 dan kalkulator rubrik mandiri di slide_16.</a:t>
+            </a:r>
+          </a:p>
+        </p:txBody>
+      </p:sp>
+      <p:sp>
+        <p:nvSpPr>
+          <p:cNvPr id="12" name="TextBox 11"/>
+          <p:cNvSpPr txBox="1"/>
+          <p:nvPr/>
+        </p:nvSpPr>
+        <p:spPr>
+          <a:xfrm>
+            <a:off x="1097280" y="4645152"/>
+            <a:ext cx="9997135" cy="320040"/>
           </a:xfrm>
           <a:prstGeom prst="rect">
             <a:avLst/>
@@ -3394,7 +3785,7 @@
           <a:lstStyle/>
           <a:p>
             <a:pPr>
-              <a:defRPr sz="950" b="1">
+              <a:defRPr sz="1000" b="1">
                 <a:solidFill>
                   <a:srgbClr val="000000"/>
                 </a:solidFill>
@@ -3402,7 +3793,149 @@
               </a:defRPr>
             </a:pPr>
             <a:r>
-              <a:t>▶ KLIK UNTUK MEMBUKA ROADMAP &amp; TAGIHAN TUGAS 1 (slide_01_roadmap_sesi_dan_tugas_1.html)</a:t>
+              <a:t>■  Anton Prafanto, S.Kom., M.T.  ■  FAKULTAS SAINS DAN TEKNOLOGI • UNIVERSITAS TERBUKA</a:t>
+            </a:r>
+          </a:p>
+        </p:txBody>
+      </p:sp>
+      <p:sp>
+        <p:nvSpPr>
+          <p:cNvPr id="13" name="Rectangle 12"/>
+          <p:cNvSpPr/>
+          <p:nvPr/>
+        </p:nvSpPr>
+        <p:spPr>
+          <a:xfrm>
+            <a:off x="1133856" y="5020056"/>
+            <a:ext cx="9997135" cy="621792"/>
+          </a:xfrm>
+          <a:prstGeom prst="rect">
+            <a:avLst/>
+          </a:prstGeom>
+          <a:solidFill>
+            <a:srgbClr val="000000"/>
+          </a:solidFill>
+          <a:ln>
+            <a:noFill/>
+          </a:ln>
+        </p:spPr>
+        <p:style>
+          <a:lnRef idx="1">
+            <a:schemeClr val="accent1"/>
+          </a:lnRef>
+          <a:fillRef idx="3">
+            <a:schemeClr val="accent1"/>
+          </a:fillRef>
+          <a:effectRef idx="2">
+            <a:schemeClr val="accent1"/>
+          </a:effectRef>
+          <a:fontRef idx="minor">
+            <a:schemeClr val="lt1"/>
+          </a:fontRef>
+        </p:style>
+        <p:txBody>
+          <a:bodyPr rtlCol="0" anchor="ctr"/>
+          <a:lstStyle/>
+          <a:p>
+            <a:pPr algn="ctr"/>
+          </a:p>
+        </p:txBody>
+      </p:sp>
+      <p:sp>
+        <p:nvSpPr>
+          <p:cNvPr id="14" name="Rectangle 13">
+            <a:hlinkClick r:id="rId2"/>
+          </p:cNvPr>
+          <p:cNvSpPr/>
+          <p:nvPr/>
+        </p:nvSpPr>
+        <p:spPr>
+          <a:xfrm>
+            <a:off x="1097280" y="4983480"/>
+            <a:ext cx="9997135" cy="621792"/>
+          </a:xfrm>
+          <a:prstGeom prst="rect">
+            <a:avLst/>
+          </a:prstGeom>
+          <a:solidFill>
+            <a:srgbClr val="FFE600"/>
+          </a:solidFill>
+          <a:ln w="25400">
+            <a:solidFill>
+              <a:srgbClr val="000000"/>
+            </a:solidFill>
+          </a:ln>
+        </p:spPr>
+        <p:style>
+          <a:lnRef idx="1">
+            <a:schemeClr val="accent1"/>
+          </a:lnRef>
+          <a:fillRef idx="3">
+            <a:schemeClr val="accent1"/>
+          </a:fillRef>
+          <a:effectRef idx="2">
+            <a:schemeClr val="accent1"/>
+          </a:effectRef>
+          <a:fontRef idx="minor">
+            <a:schemeClr val="lt1"/>
+          </a:fontRef>
+        </p:style>
+        <p:txBody>
+          <a:bodyPr rtlCol="0" anchor="ctr"/>
+          <a:lstStyle/>
+          <a:p>
+            <a:pPr algn="ctr"/>
+          </a:p>
+        </p:txBody>
+      </p:sp>
+      <p:sp>
+        <p:nvSpPr>
+          <p:cNvPr id="15" name="TextBox 14"/>
+          <p:cNvSpPr txBox="1"/>
+          <p:nvPr/>
+        </p:nvSpPr>
+        <p:spPr>
+          <a:xfrm>
+            <a:off x="1188720" y="5020056"/>
+            <a:ext cx="9814255" cy="548640"/>
+          </a:xfrm>
+          <a:prstGeom prst="rect">
+            <a:avLst/>
+          </a:prstGeom>
+          <a:noFill/>
+        </p:spPr>
+        <p:txBody>
+          <a:bodyPr wrap="square">
+            <a:spAutoFit/>
+          </a:bodyPr>
+          <a:lstStyle/>
+          <a:p>
+            <a:pPr>
+              <a:spcAft>
+                <a:spcPts val="200"/>
+              </a:spcAft>
+              <a:defRPr sz="1000" b="1">
+                <a:solidFill>
+                  <a:srgbClr val="000000"/>
+                </a:solidFill>
+                <a:latin typeface="Segoe UI"/>
+              </a:defRPr>
+            </a:pPr>
+            <a:r>
+              <a:t>▶ KLIK DI SINI UNTUK MEMBUKA BERKAS INTERAKTIF ROADMAP &amp; TAGIHAN TUGAS 1 (slide_01_roadmap_sesi_dan_tugas_1.html)</a:t>
+            </a:r>
+          </a:p>
+          <a:p>
+            <a:pPr>
+              <a:defRPr sz="850">
+                <a:solidFill>
+                  <a:srgbClr val="3C3C3C"/>
+                </a:solidFill>
+                <a:latin typeface="Segoe UI"/>
+              </a:defRPr>
+            </a:pPr>
+            <a:r>
+              <a:t>Tautan resmi menuju repositori GitHub tuweb_mobile2025 • Siap dieksekusi langsung di Google Chrome tanpa instalasi server!</a:t>
             </a:r>
           </a:p>
         </p:txBody>

</xml_diff>